<commit_message>
update the system configuration diagram
</commit_message>
<xml_diff>
--- a/kong-konnect/ai-gateway/image/kong-konnect-ai-gateway_overview.pptx
+++ b/kong-konnect/ai-gateway/image/kong-konnect-ai-gateway_overview.pptx
@@ -4800,7 +4800,7 @@
         </p:nvSpPr>
         <p:spPr>
           <a:xfrm>
-            <a:off x="6638612" y="3305639"/>
+            <a:off x="6638612" y="3442799"/>
             <a:ext cx="1886735" cy="215444"/>
           </a:xfrm>
           <a:prstGeom prst="rect">
@@ -4853,7 +4853,7 @@
         </p:nvSpPr>
         <p:spPr>
           <a:xfrm>
-            <a:off x="7677405" y="2376483"/>
+            <a:off x="7677405" y="2507031"/>
             <a:ext cx="1152000" cy="540000"/>
           </a:xfrm>
           <a:prstGeom prst="ellipse">
@@ -4908,7 +4908,7 @@
         </p:nvSpPr>
         <p:spPr>
           <a:xfrm>
-            <a:off x="7788237" y="2951541"/>
+            <a:off x="7788237" y="3088701"/>
             <a:ext cx="948978" cy="276999"/>
           </a:xfrm>
           <a:prstGeom prst="rect">
@@ -5170,7 +5170,7 @@
         </p:nvSpPr>
         <p:spPr>
           <a:xfrm>
-            <a:off x="4000493" y="2096673"/>
+            <a:off x="4000493" y="2097846"/>
             <a:ext cx="900000" cy="684000"/>
           </a:xfrm>
           <a:prstGeom prst="roundRect">
@@ -5226,24 +5226,14 @@
           <a:p>
             <a:pPr algn="ctr"/>
             <a:r>
-              <a:rPr kumimoji="1" lang="en-US" altLang="ja-JP" sz="700" dirty="0">
+              <a:rPr kumimoji="1" lang="en-US" altLang="ja-JP" sz="700" dirty="0" err="1">
                 <a:solidFill>
                   <a:schemeClr val="tx1"/>
                 </a:solidFill>
                 <a:latin typeface="Meiryo UI" panose="020B0604030504040204" pitchFamily="50" charset="-128"/>
                 <a:ea typeface="Meiryo UI" panose="020B0604030504040204" pitchFamily="50" charset="-128"/>
               </a:rPr>
-              <a:t>Kong-</a:t>
-            </a:r>
-            <a:r>
-              <a:rPr kumimoji="1" lang="en-US" altLang="ja-JP" sz="700" dirty="0" err="1">
-                <a:solidFill>
-                  <a:schemeClr val="tx1"/>
-                </a:solidFill>
-                <a:latin typeface="Meiryo UI" panose="020B0604030504040204" pitchFamily="50" charset="-128"/>
-                <a:ea typeface="Meiryo UI" panose="020B0604030504040204" pitchFamily="50" charset="-128"/>
-              </a:rPr>
-              <a:t>dp</a:t>
+              <a:t>kong-dp</a:t>
             </a:r>
             <a:endParaRPr kumimoji="1" lang="en-US" altLang="ja-JP" sz="700" dirty="0">
               <a:solidFill>
@@ -5325,7 +5315,7 @@
         </p:nvSpPr>
         <p:spPr>
           <a:xfrm>
-            <a:off x="1178314" y="2622971"/>
+            <a:off x="1178314" y="2677491"/>
             <a:ext cx="439223" cy="123111"/>
           </a:xfrm>
           <a:prstGeom prst="rect">
@@ -5428,13 +5418,12 @@
           </p:cNvPr>
           <p:cNvCxnSpPr>
             <a:cxnSpLocks/>
-            <a:endCxn id="102" idx="1"/>
           </p:cNvCxnSpPr>
           <p:nvPr/>
         </p:nvCxnSpPr>
         <p:spPr>
-          <a:xfrm flipV="1">
-            <a:off x="1135797" y="2605983"/>
+          <a:xfrm>
+            <a:off x="1135797" y="2660346"/>
             <a:ext cx="562419" cy="0"/>
           </a:xfrm>
           <a:prstGeom prst="straightConnector1">
@@ -5478,7 +5467,7 @@
         </p:nvCxnSpPr>
         <p:spPr>
           <a:xfrm>
-            <a:off x="6231978" y="3268280"/>
+            <a:off x="6231978" y="3405440"/>
             <a:ext cx="2700000" cy="0"/>
           </a:xfrm>
           <a:prstGeom prst="straightConnector1">
@@ -5571,7 +5560,7 @@
         </p:blipFill>
         <p:spPr>
           <a:xfrm>
-            <a:off x="1698216" y="2484483"/>
+            <a:off x="1698216" y="2538846"/>
             <a:ext cx="324000" cy="243000"/>
           </a:xfrm>
           <a:prstGeom prst="rect">
@@ -5597,7 +5586,7 @@
         </p:nvCxnSpPr>
         <p:spPr>
           <a:xfrm>
-            <a:off x="4000493" y="2438673"/>
+            <a:off x="4000493" y="2439846"/>
             <a:ext cx="900000" cy="0"/>
           </a:xfrm>
           <a:prstGeom prst="straightConnector1">
@@ -5640,7 +5629,7 @@
         </p:nvSpPr>
         <p:spPr>
           <a:xfrm>
-            <a:off x="1193541" y="2300576"/>
+            <a:off x="1193541" y="2276991"/>
             <a:ext cx="408766" cy="123111"/>
           </a:xfrm>
           <a:prstGeom prst="rect">
@@ -5690,13 +5679,12 @@
           </p:cNvPr>
           <p:cNvCxnSpPr>
             <a:cxnSpLocks/>
-            <a:endCxn id="122" idx="1"/>
           </p:cNvCxnSpPr>
           <p:nvPr/>
         </p:nvCxnSpPr>
         <p:spPr>
           <a:xfrm>
-            <a:off x="1135797" y="2278287"/>
+            <a:off x="1135797" y="2259846"/>
             <a:ext cx="562419" cy="0"/>
           </a:xfrm>
           <a:prstGeom prst="straightConnector1">
@@ -5752,7 +5740,7 @@
         </p:blipFill>
         <p:spPr>
           <a:xfrm>
-            <a:off x="1698216" y="2116287"/>
+            <a:off x="1698216" y="2097846"/>
             <a:ext cx="324000" cy="324000"/>
           </a:xfrm>
           <a:prstGeom prst="rect">
@@ -5778,8 +5766,8 @@
         </p:nvCxnSpPr>
         <p:spPr>
           <a:xfrm>
-            <a:off x="2022216" y="2278287"/>
-            <a:ext cx="1978277" cy="160386"/>
+            <a:off x="2022216" y="2259846"/>
+            <a:ext cx="1978277" cy="180000"/>
           </a:xfrm>
           <a:prstGeom prst="bentConnector3">
             <a:avLst/>
@@ -5824,8 +5812,8 @@
         </p:nvCxnSpPr>
         <p:spPr>
           <a:xfrm flipV="1">
-            <a:off x="2022216" y="2438673"/>
-            <a:ext cx="1978277" cy="167310"/>
+            <a:off x="2022216" y="2439846"/>
+            <a:ext cx="1978277" cy="220500"/>
           </a:xfrm>
           <a:prstGeom prst="bentConnector3">
             <a:avLst/>
@@ -5870,8 +5858,8 @@
         </p:nvCxnSpPr>
         <p:spPr>
           <a:xfrm>
-            <a:off x="4900493" y="2438673"/>
-            <a:ext cx="2776912" cy="207810"/>
+            <a:off x="4900493" y="2439846"/>
+            <a:ext cx="2776912" cy="337185"/>
           </a:xfrm>
           <a:prstGeom prst="straightConnector1">
             <a:avLst/>
@@ -5991,7 +5979,6 @@
           </p:cNvPr>
           <p:cNvCxnSpPr>
             <a:cxnSpLocks/>
-            <a:endCxn id="137" idx="1"/>
           </p:cNvCxnSpPr>
           <p:nvPr/>
         </p:nvCxnSpPr>
@@ -6039,7 +6026,7 @@
         </p:nvSpPr>
         <p:spPr>
           <a:xfrm>
-            <a:off x="1193541" y="3240987"/>
+            <a:off x="1193541" y="3237549"/>
             <a:ext cx="408766" cy="123111"/>
           </a:xfrm>
           <a:prstGeom prst="rect">
@@ -6149,8 +6136,8 @@
         </p:nvCxnSpPr>
         <p:spPr>
           <a:xfrm>
-            <a:off x="4450493" y="2780673"/>
-            <a:ext cx="0" cy="151731"/>
+            <a:off x="4450493" y="2781846"/>
+            <a:ext cx="0" cy="150558"/>
           </a:xfrm>
           <a:prstGeom prst="straightConnector1">
             <a:avLst/>
@@ -6191,8 +6178,8 @@
         </p:nvSpPr>
         <p:spPr>
           <a:xfrm>
-            <a:off x="6333695" y="2050863"/>
-            <a:ext cx="972000" cy="360000"/>
+            <a:off x="6339410" y="1682946"/>
+            <a:ext cx="1008000" cy="828000"/>
           </a:xfrm>
           <a:prstGeom prst="roundRect">
             <a:avLst>
@@ -6219,7 +6206,7 @@
           </a:fontRef>
         </p:style>
         <p:txBody>
-          <a:bodyPr wrap="none" lIns="180000" rIns="0" rtlCol="0" anchor="ctr" anchorCtr="0"/>
+          <a:bodyPr wrap="none" lIns="180000" rIns="0" rtlCol="0" anchor="t" anchorCtr="0"/>
           <a:lstStyle/>
           <a:p>
             <a:pPr algn="ctr"/>
@@ -6231,7 +6218,7 @@
                 <a:latin typeface="Meiryo UI" panose="020B0604030504040204" pitchFamily="50" charset="-128"/>
                 <a:ea typeface="Meiryo UI" panose="020B0604030504040204" pitchFamily="50" charset="-128"/>
               </a:rPr>
-              <a:t>Ollama</a:t>
+              <a:t>ollama</a:t>
             </a:r>
             <a:endParaRPr kumimoji="1" lang="en-US" altLang="ja-JP" sz="800" dirty="0">
               <a:solidFill>
@@ -6274,8 +6261,8 @@
         </p:nvCxnSpPr>
         <p:spPr>
           <a:xfrm flipV="1">
-            <a:off x="4900493" y="2230863"/>
-            <a:ext cx="1433202" cy="207810"/>
+            <a:off x="4900493" y="2096946"/>
+            <a:ext cx="1438917" cy="342900"/>
           </a:xfrm>
           <a:prstGeom prst="straightConnector1">
             <a:avLst/>
@@ -6418,7 +6405,7 @@
         </p:nvSpPr>
         <p:spPr>
           <a:xfrm>
-            <a:off x="1193541" y="1097867"/>
+            <a:off x="1193541" y="1086594"/>
             <a:ext cx="439223" cy="123111"/>
           </a:xfrm>
           <a:prstGeom prst="rect">
@@ -6493,51 +6480,6 @@
           </a:prstGeom>
         </p:spPr>
       </p:pic>
-      <p:cxnSp>
-        <p:nvCxnSpPr>
-          <p:cNvPr id="174" name="直線矢印コネクタ 173">
-            <a:extLst>
-              <a:ext uri="{FF2B5EF4-FFF2-40B4-BE49-F238E27FC236}">
-                <a16:creationId xmlns:a16="http://schemas.microsoft.com/office/drawing/2014/main" id="{2A8DAA76-18EB-9152-4E54-89131CDD1545}"/>
-              </a:ext>
-            </a:extLst>
-          </p:cNvPr>
-          <p:cNvCxnSpPr>
-            <a:cxnSpLocks/>
-            <a:endCxn id="175" idx="1"/>
-          </p:cNvCxnSpPr>
-          <p:nvPr/>
-        </p:nvCxnSpPr>
-        <p:spPr>
-          <a:xfrm>
-            <a:off x="1135797" y="1069449"/>
-            <a:ext cx="562419" cy="0"/>
-          </a:xfrm>
-          <a:prstGeom prst="straightConnector1">
-            <a:avLst/>
-          </a:prstGeom>
-          <a:ln w="12700">
-            <a:solidFill>
-              <a:schemeClr val="tx1"/>
-            </a:solidFill>
-            <a:tailEnd type="none" w="lg" len="sm"/>
-          </a:ln>
-        </p:spPr>
-        <p:style>
-          <a:lnRef idx="1">
-            <a:schemeClr val="accent1"/>
-          </a:lnRef>
-          <a:fillRef idx="0">
-            <a:schemeClr val="accent1"/>
-          </a:fillRef>
-          <a:effectRef idx="0">
-            <a:schemeClr val="accent1"/>
-          </a:effectRef>
-          <a:fontRef idx="minor">
-            <a:schemeClr val="tx1"/>
-          </a:fontRef>
-        </p:style>
-      </p:cxnSp>
       <p:sp>
         <p:nvSpPr>
           <p:cNvPr id="176" name="テキスト ボックス 175">
@@ -6552,7 +6494,7 @@
         </p:nvSpPr>
         <p:spPr>
           <a:xfrm>
-            <a:off x="1193541" y="758327"/>
+            <a:off x="1193541" y="764613"/>
             <a:ext cx="408766" cy="123111"/>
           </a:xfrm>
           <a:prstGeom prst="rect">
@@ -6591,6 +6533,50 @@
           </a:p>
         </p:txBody>
       </p:sp>
+      <p:cxnSp>
+        <p:nvCxnSpPr>
+          <p:cNvPr id="174" name="直線矢印コネクタ 173">
+            <a:extLst>
+              <a:ext uri="{FF2B5EF4-FFF2-40B4-BE49-F238E27FC236}">
+                <a16:creationId xmlns:a16="http://schemas.microsoft.com/office/drawing/2014/main" id="{2A8DAA76-18EB-9152-4E54-89131CDD1545}"/>
+              </a:ext>
+            </a:extLst>
+          </p:cNvPr>
+          <p:cNvCxnSpPr>
+            <a:cxnSpLocks/>
+          </p:cNvCxnSpPr>
+          <p:nvPr/>
+        </p:nvCxnSpPr>
+        <p:spPr>
+          <a:xfrm>
+            <a:off x="1135797" y="1069449"/>
+            <a:ext cx="562419" cy="0"/>
+          </a:xfrm>
+          <a:prstGeom prst="straightConnector1">
+            <a:avLst/>
+          </a:prstGeom>
+          <a:ln w="12700">
+            <a:solidFill>
+              <a:schemeClr val="tx1"/>
+            </a:solidFill>
+            <a:tailEnd type="none" w="lg" len="sm"/>
+          </a:ln>
+        </p:spPr>
+        <p:style>
+          <a:lnRef idx="1">
+            <a:schemeClr val="accent1"/>
+          </a:lnRef>
+          <a:fillRef idx="0">
+            <a:schemeClr val="accent1"/>
+          </a:fillRef>
+          <a:effectRef idx="0">
+            <a:schemeClr val="accent1"/>
+          </a:effectRef>
+          <a:fontRef idx="minor">
+            <a:schemeClr val="tx1"/>
+          </a:fontRef>
+        </p:style>
+      </p:cxnSp>
       <p:pic>
         <p:nvPicPr>
           <p:cNvPr id="178" name="図 177" descr="アイコン&#10;&#10;自動的に生成された説明">
@@ -6638,7 +6624,6 @@
           </p:cNvPr>
           <p:cNvCxnSpPr>
             <a:cxnSpLocks/>
-            <a:endCxn id="178" idx="1"/>
           </p:cNvCxnSpPr>
           <p:nvPr/>
         </p:nvCxnSpPr>
@@ -6764,6 +6749,51 @@
           </a:fontRef>
         </p:style>
       </p:cxnSp>
+      <p:cxnSp>
+        <p:nvCxnSpPr>
+          <p:cNvPr id="187" name="コネクタ: 曲線 186">
+            <a:extLst>
+              <a:ext uri="{FF2B5EF4-FFF2-40B4-BE49-F238E27FC236}">
+                <a16:creationId xmlns:a16="http://schemas.microsoft.com/office/drawing/2014/main" id="{D811221E-49CD-DDFA-8624-F33C7F7F5D0C}"/>
+              </a:ext>
+            </a:extLst>
+          </p:cNvPr>
+          <p:cNvCxnSpPr>
+            <a:cxnSpLocks/>
+            <a:stCxn id="68" idx="0"/>
+          </p:cNvCxnSpPr>
+          <p:nvPr/>
+        </p:nvCxnSpPr>
+        <p:spPr>
+          <a:xfrm rot="5400000" flipH="1" flipV="1">
+            <a:off x="5535666" y="-43895"/>
+            <a:ext cx="1056568" cy="3226914"/>
+          </a:xfrm>
+          <a:prstGeom prst="curvedConnector2">
+            <a:avLst/>
+          </a:prstGeom>
+          <a:ln w="12700">
+            <a:solidFill>
+              <a:schemeClr val="tx1"/>
+            </a:solidFill>
+            <a:tailEnd type="arrow" w="lg" len="sm"/>
+          </a:ln>
+        </p:spPr>
+        <p:style>
+          <a:lnRef idx="1">
+            <a:schemeClr val="accent1"/>
+          </a:lnRef>
+          <a:fillRef idx="0">
+            <a:schemeClr val="accent1"/>
+          </a:fillRef>
+          <a:effectRef idx="0">
+            <a:schemeClr val="accent1"/>
+          </a:effectRef>
+          <a:fontRef idx="minor">
+            <a:schemeClr val="tx1"/>
+          </a:fontRef>
+        </p:style>
+      </p:cxnSp>
       <p:sp>
         <p:nvSpPr>
           <p:cNvPr id="181" name="テキスト ボックス 180">
@@ -6778,7 +6808,7 @@
         </p:nvSpPr>
         <p:spPr>
           <a:xfrm>
-            <a:off x="2975843" y="1097867"/>
+            <a:off x="2610293" y="1086594"/>
             <a:ext cx="240450" cy="123111"/>
           </a:xfrm>
           <a:prstGeom prst="rect">
@@ -6817,51 +6847,6 @@
           </a:p>
         </p:txBody>
       </p:sp>
-      <p:cxnSp>
-        <p:nvCxnSpPr>
-          <p:cNvPr id="187" name="コネクタ: 曲線 186">
-            <a:extLst>
-              <a:ext uri="{FF2B5EF4-FFF2-40B4-BE49-F238E27FC236}">
-                <a16:creationId xmlns:a16="http://schemas.microsoft.com/office/drawing/2014/main" id="{D811221E-49CD-DDFA-8624-F33C7F7F5D0C}"/>
-              </a:ext>
-            </a:extLst>
-          </p:cNvPr>
-          <p:cNvCxnSpPr>
-            <a:cxnSpLocks/>
-            <a:stCxn id="68" idx="0"/>
-          </p:cNvCxnSpPr>
-          <p:nvPr/>
-        </p:nvCxnSpPr>
-        <p:spPr>
-          <a:xfrm rot="5400000" flipH="1" flipV="1">
-            <a:off x="5536252" y="-44482"/>
-            <a:ext cx="1055396" cy="3226914"/>
-          </a:xfrm>
-          <a:prstGeom prst="curvedConnector2">
-            <a:avLst/>
-          </a:prstGeom>
-          <a:ln w="12700">
-            <a:solidFill>
-              <a:schemeClr val="tx1"/>
-            </a:solidFill>
-            <a:tailEnd type="arrow" w="lg" len="sm"/>
-          </a:ln>
-        </p:spPr>
-        <p:style>
-          <a:lnRef idx="1">
-            <a:schemeClr val="accent1"/>
-          </a:lnRef>
-          <a:fillRef idx="0">
-            <a:schemeClr val="accent1"/>
-          </a:fillRef>
-          <a:effectRef idx="0">
-            <a:schemeClr val="accent1"/>
-          </a:effectRef>
-          <a:fontRef idx="minor">
-            <a:schemeClr val="tx1"/>
-          </a:fontRef>
-        </p:style>
-      </p:cxnSp>
       <p:pic>
         <p:nvPicPr>
           <p:cNvPr id="9" name="図 8">
@@ -6884,38 +6869,8 @@
         </p:blipFill>
         <p:spPr>
           <a:xfrm>
-            <a:off x="8019405" y="2412483"/>
+            <a:off x="8019405" y="2543031"/>
             <a:ext cx="468000" cy="468000"/>
-          </a:xfrm>
-          <a:prstGeom prst="rect">
-            <a:avLst/>
-          </a:prstGeom>
-        </p:spPr>
-      </p:pic>
-      <p:pic>
-        <p:nvPicPr>
-          <p:cNvPr id="12" name="図 11">
-            <a:extLst>
-              <a:ext uri="{FF2B5EF4-FFF2-40B4-BE49-F238E27FC236}">
-                <a16:creationId xmlns:a16="http://schemas.microsoft.com/office/drawing/2014/main" id="{134CCAE4-6507-18A0-CF09-097632775040}"/>
-              </a:ext>
-            </a:extLst>
-          </p:cNvPr>
-          <p:cNvPicPr>
-            <a:picLocks noChangeAspect="1"/>
-          </p:cNvPicPr>
-          <p:nvPr/>
-        </p:nvPicPr>
-        <p:blipFill>
-          <a:blip r:embed="rId13"/>
-          <a:stretch>
-            <a:fillRect/>
-          </a:stretch>
-        </p:blipFill>
-        <p:spPr>
-          <a:xfrm>
-            <a:off x="6409370" y="2104863"/>
-            <a:ext cx="190845" cy="252000"/>
           </a:xfrm>
           <a:prstGeom prst="rect">
             <a:avLst/>
@@ -6936,7 +6891,7 @@
         </p:nvSpPr>
         <p:spPr>
           <a:xfrm>
-            <a:off x="5624704" y="2105995"/>
+            <a:off x="5676139" y="1934545"/>
             <a:ext cx="528991" cy="107722"/>
           </a:xfrm>
           <a:prstGeom prst="rect">
@@ -6964,6 +6919,184 @@
               <a:t>Port=11434</a:t>
             </a:r>
             <a:endParaRPr kumimoji="1" lang="ja-JP" altLang="en-US" sz="700" dirty="0">
+              <a:effectLst>
+                <a:glow rad="63500">
+                  <a:schemeClr val="bg1"/>
+                </a:glow>
+              </a:effectLst>
+              <a:latin typeface="Meiryo UI" panose="020B0604030504040204" pitchFamily="50" charset="-128"/>
+              <a:ea typeface="Meiryo UI" panose="020B0604030504040204" pitchFamily="50" charset="-128"/>
+            </a:endParaRPr>
+          </a:p>
+        </p:txBody>
+      </p:sp>
+      <p:sp>
+        <p:nvSpPr>
+          <p:cNvPr id="11" name="テキスト ボックス 10">
+            <a:extLst>
+              <a:ext uri="{FF2B5EF4-FFF2-40B4-BE49-F238E27FC236}">
+                <a16:creationId xmlns:a16="http://schemas.microsoft.com/office/drawing/2014/main" id="{DF02E3D0-FCD6-D1AA-9D76-BF4ED2954ECA}"/>
+              </a:ext>
+            </a:extLst>
+          </p:cNvPr>
+          <p:cNvSpPr txBox="1"/>
+          <p:nvPr/>
+        </p:nvSpPr>
+        <p:spPr>
+          <a:xfrm>
+            <a:off x="6355813" y="2051484"/>
+            <a:ext cx="975194" cy="430887"/>
+          </a:xfrm>
+          <a:prstGeom prst="rect">
+            <a:avLst/>
+          </a:prstGeom>
+          <a:noFill/>
+        </p:spPr>
+        <p:txBody>
+          <a:bodyPr wrap="none" lIns="36000" tIns="0" rIns="36000" bIns="0" rtlCol="0">
+            <a:spAutoFit/>
+          </a:bodyPr>
+          <a:lstStyle/>
+          <a:p>
+            <a:pPr marL="92075" indent="-92075">
+              <a:buFont typeface="Arial" panose="020B0604020202020204" pitchFamily="34" charset="0"/>
+              <a:buChar char="•"/>
+            </a:pPr>
+            <a:r>
+              <a:rPr kumimoji="1" lang="en-US" altLang="ja-JP" sz="700" dirty="0">
+                <a:effectLst/>
+                <a:latin typeface="Meiryo UI" panose="020B0604030504040204" pitchFamily="50" charset="-128"/>
+                <a:ea typeface="Meiryo UI" panose="020B0604030504040204" pitchFamily="50" charset="-128"/>
+              </a:rPr>
+              <a:t>qwen2.5:1.5b</a:t>
+            </a:r>
+          </a:p>
+          <a:p>
+            <a:pPr marL="92075" indent="-92075">
+              <a:buFont typeface="Arial" panose="020B0604020202020204" pitchFamily="34" charset="0"/>
+              <a:buChar char="•"/>
+            </a:pPr>
+            <a:r>
+              <a:rPr kumimoji="1" lang="en-US" altLang="ja-JP" sz="700" dirty="0">
+                <a:effectLst/>
+                <a:latin typeface="Meiryo UI" panose="020B0604030504040204" pitchFamily="50" charset="-128"/>
+                <a:ea typeface="Meiryo UI" panose="020B0604030504040204" pitchFamily="50" charset="-128"/>
+              </a:rPr>
+              <a:t>qwen2.5:3b</a:t>
+            </a:r>
+          </a:p>
+          <a:p>
+            <a:pPr marL="92075" indent="-92075">
+              <a:buFont typeface="Arial" panose="020B0604020202020204" pitchFamily="34" charset="0"/>
+              <a:buChar char="•"/>
+            </a:pPr>
+            <a:r>
+              <a:rPr kumimoji="1" lang="en-US" altLang="ja-JP" sz="700" dirty="0" err="1">
+                <a:effectLst/>
+                <a:latin typeface="Meiryo UI" panose="020B0604030504040204" pitchFamily="50" charset="-128"/>
+                <a:ea typeface="Meiryo UI" panose="020B0604030504040204" pitchFamily="50" charset="-128"/>
+              </a:rPr>
+              <a:t>tinyllama</a:t>
+            </a:r>
+            <a:endParaRPr kumimoji="1" lang="en-US" altLang="ja-JP" sz="700" dirty="0">
+              <a:effectLst/>
+              <a:latin typeface="Meiryo UI" panose="020B0604030504040204" pitchFamily="50" charset="-128"/>
+              <a:ea typeface="Meiryo UI" panose="020B0604030504040204" pitchFamily="50" charset="-128"/>
+            </a:endParaRPr>
+          </a:p>
+          <a:p>
+            <a:pPr marL="92075" indent="-92075">
+              <a:buFont typeface="Arial" panose="020B0604020202020204" pitchFamily="34" charset="0"/>
+              <a:buChar char="•"/>
+            </a:pPr>
+            <a:r>
+              <a:rPr kumimoji="1" lang="en-US" altLang="ja-JP" sz="700" dirty="0">
+                <a:effectLst/>
+                <a:latin typeface="Meiryo UI" panose="020B0604030504040204" pitchFamily="50" charset="-128"/>
+                <a:ea typeface="Meiryo UI" panose="020B0604030504040204" pitchFamily="50" charset="-128"/>
+              </a:rPr>
+              <a:t>nomic-embed-text</a:t>
+            </a:r>
+            <a:endParaRPr kumimoji="1" lang="ja-JP" altLang="en-US" sz="700" dirty="0">
+              <a:effectLst/>
+              <a:latin typeface="Meiryo UI" panose="020B0604030504040204" pitchFamily="50" charset="-128"/>
+              <a:ea typeface="Meiryo UI" panose="020B0604030504040204" pitchFamily="50" charset="-128"/>
+            </a:endParaRPr>
+          </a:p>
+        </p:txBody>
+      </p:sp>
+      <p:pic>
+        <p:nvPicPr>
+          <p:cNvPr id="12" name="図 11">
+            <a:extLst>
+              <a:ext uri="{FF2B5EF4-FFF2-40B4-BE49-F238E27FC236}">
+                <a16:creationId xmlns:a16="http://schemas.microsoft.com/office/drawing/2014/main" id="{134CCAE4-6507-18A0-CF09-097632775040}"/>
+              </a:ext>
+            </a:extLst>
+          </p:cNvPr>
+          <p:cNvPicPr>
+            <a:picLocks noChangeAspect="1"/>
+          </p:cNvPicPr>
+          <p:nvPr/>
+        </p:nvPicPr>
+        <p:blipFill>
+          <a:blip r:embed="rId13"/>
+          <a:stretch>
+            <a:fillRect/>
+          </a:stretch>
+        </p:blipFill>
+        <p:spPr>
+          <a:xfrm>
+            <a:off x="6442280" y="1751526"/>
+            <a:ext cx="190845" cy="252000"/>
+          </a:xfrm>
+          <a:prstGeom prst="rect">
+            <a:avLst/>
+          </a:prstGeom>
+        </p:spPr>
+      </p:pic>
+      <p:sp>
+        <p:nvSpPr>
+          <p:cNvPr id="13" name="テキスト ボックス 12">
+            <a:extLst>
+              <a:ext uri="{FF2B5EF4-FFF2-40B4-BE49-F238E27FC236}">
+                <a16:creationId xmlns:a16="http://schemas.microsoft.com/office/drawing/2014/main" id="{303072B1-3C30-F8E6-6969-805DE0553D19}"/>
+              </a:ext>
+            </a:extLst>
+          </p:cNvPr>
+          <p:cNvSpPr txBox="1"/>
+          <p:nvPr/>
+        </p:nvSpPr>
+        <p:spPr>
+          <a:xfrm>
+            <a:off x="2639147" y="2677491"/>
+            <a:ext cx="182742" cy="123111"/>
+          </a:xfrm>
+          <a:prstGeom prst="rect">
+            <a:avLst/>
+          </a:prstGeom>
+          <a:noFill/>
+        </p:spPr>
+        <p:txBody>
+          <a:bodyPr wrap="none" lIns="0" tIns="0" rIns="0" bIns="0" rtlCol="0">
+            <a:spAutoFit/>
+          </a:bodyPr>
+          <a:lstStyle/>
+          <a:p>
+            <a:pPr algn="ctr"/>
+            <a:r>
+              <a:rPr kumimoji="1" lang="en-US" altLang="ja-JP" sz="800" dirty="0">
+                <a:effectLst>
+                  <a:glow rad="63500">
+                    <a:schemeClr val="bg1"/>
+                  </a:glow>
+                </a:effectLst>
+                <a:latin typeface="Meiryo UI" panose="020B0604030504040204" pitchFamily="50" charset="-128"/>
+                <a:ea typeface="Meiryo UI" panose="020B0604030504040204" pitchFamily="50" charset="-128"/>
+              </a:rPr>
+              <a:t>curl</a:t>
+            </a:r>
+            <a:endParaRPr kumimoji="1" lang="ja-JP" altLang="en-US" sz="800" dirty="0">
               <a:effectLst>
                 <a:glow rad="63500">
                   <a:schemeClr val="bg1"/>

</xml_diff>